<commit_message>
fix & polish: comprehensive review, studio canvas editing, case study rendering, export sync, and robust runners
</commit_message>
<xml_diff>
--- a/ai_presentation_generator/outputs/presentation_pres_demo_healthcare.pptx
+++ b/ai_presentation_generator/outputs/presentation_pres_demo_healthcare.pptx
@@ -591,6 +591,23 @@
           <a:p/>
           <a:p>
             <a:r>
+              <a:t>Slide Purpose: Introduce the role and transformational potential of AI in modern clinical workflows.</a:t>
+            </a:r>
+          </a:p>
+          <a:p/>
+          <a:p>
+            <a:r>
+              <a:t>Case Study / Real-World Application:</a:t>
+            </a:r>
+          </a:p>
+          <a:p>
+            <a:r>
+              <a:t>FDA approval of autonomous AI diagnostic devices for early diabetic retinopathy detection without ophthalmologist intervention.</a:t>
+            </a:r>
+          </a:p>
+          <a:p/>
+          <a:p>
+            <a:r>
               <a:t>Speaker Notes:</a:t>
             </a:r>
           </a:p>
@@ -672,6 +689,23 @@
           <a:p/>
           <a:p>
             <a:r>
+              <a:t>Slide Purpose: Examine historical milestones leading to modern clinical transformers.</a:t>
+            </a:r>
+          </a:p>
+          <a:p/>
+          <a:p>
+            <a:r>
+              <a:t>Case Study / Real-World Application:</a:t>
+            </a:r>
+          </a:p>
+          <a:p>
+            <a:r>
+              <a:t>Stanford CheXNeXt model matching 11 practicing radiologists across 14 distinct chest radiograph pathologies.</a:t>
+            </a:r>
+          </a:p>
+          <a:p/>
+          <a:p>
+            <a:r>
               <a:t>Speaker Notes:</a:t>
             </a:r>
           </a:p>
@@ -753,6 +787,23 @@
           <a:p/>
           <a:p>
             <a:r>
+              <a:t>Slide Purpose: Explain the principal deep learning architectures powering healthcare intelligence.</a:t>
+            </a:r>
+          </a:p>
+          <a:p/>
+          <a:p>
+            <a:r>
+              <a:t>Case Study / Real-World Application:</a:t>
+            </a:r>
+          </a:p>
+          <a:p>
+            <a:r>
+              <a:t>DeepMind AlphaFold resolving the 3D structure of over 200 million cataloged proteins, compressing decades of wet-lab research.</a:t>
+            </a:r>
+          </a:p>
+          <a:p/>
+          <a:p>
+            <a:r>
               <a:t>Speaker Notes:</a:t>
             </a:r>
           </a:p>
@@ -834,6 +885,23 @@
           <a:p/>
           <a:p>
             <a:r>
+              <a:t>Slide Purpose: Analyze computer-aided detection and real-time clinical screening pipelines.</a:t>
+            </a:r>
+          </a:p>
+          <a:p/>
+          <a:p>
+            <a:r>
+              <a:t>Case Study / Real-World Application:</a:t>
+            </a:r>
+          </a:p>
+          <a:p>
+            <a:r>
+              <a:t>Johns Hopkins hospital deployment of machine learning early-warning algorithms reducing sepsis patient mortality by 18.2%.</a:t>
+            </a:r>
+          </a:p>
+          <a:p/>
+          <a:p>
+            <a:r>
               <a:t>Speaker Notes:</a:t>
             </a:r>
           </a:p>
@@ -915,6 +983,23 @@
           <a:p/>
           <a:p>
             <a:r>
+              <a:t>Slide Purpose: Demonstrate applied clinical operations, remote monitoring, and workflow optimization.</a:t>
+            </a:r>
+          </a:p>
+          <a:p/>
+          <a:p>
+            <a:r>
+              <a:t>Case Study / Real-World Application:</a:t>
+            </a:r>
+          </a:p>
+          <a:p>
+            <a:r>
+              <a:t>Epic Systems ambient listening copilot eliminating 1.5 hours of physician administrative charting per clinical shift.</a:t>
+            </a:r>
+          </a:p>
+          <a:p/>
+          <a:p>
+            <a:r>
               <a:t>Speaker Notes:</a:t>
             </a:r>
           </a:p>
@@ -996,6 +1081,23 @@
           <a:p/>
           <a:p>
             <a:r>
+              <a:t>Slide Purpose: Critically evaluate clinical advantages alongside privacy, bias, and regulatory bottlenecks.</a:t>
+            </a:r>
+          </a:p>
+          <a:p/>
+          <a:p>
+            <a:r>
+              <a:t>Case Study / Real-World Application:</a:t>
+            </a:r>
+          </a:p>
+          <a:p>
+            <a:r>
+              <a:t>Empirical study revealing diagnostic performance degradation when skin lesion algorithms were tested across diverse under-represented skin tones.</a:t>
+            </a:r>
+          </a:p>
+          <a:p/>
+          <a:p>
+            <a:r>
               <a:t>Speaker Notes:</a:t>
             </a:r>
           </a:p>
@@ -1077,6 +1179,23 @@
           <a:p/>
           <a:p>
             <a:r>
+              <a:t>Slide Purpose: Explore next-generation frontiers in personalized genomics and federated health networks.</a:t>
+            </a:r>
+          </a:p>
+          <a:p/>
+          <a:p>
+            <a:r>
+              <a:t>Case Study / Real-World Application:</a:t>
+            </a:r>
+          </a:p>
+          <a:p>
+            <a:r>
+              <a:t>Consortium of 20 cancer centers across Europe training federated glioma segmentation models preserving GDPR patient privacy.</a:t>
+            </a:r>
+          </a:p>
+          <a:p/>
+          <a:p>
+            <a:r>
               <a:t>Speaker Notes:</a:t>
             </a:r>
           </a:p>
@@ -1153,6 +1272,23 @@
           <a:p>
             <a:r>
               <a:t>Allocated Pacing: 1.5 min</a:t>
+            </a:r>
+          </a:p>
+          <a:p/>
+          <a:p>
+            <a:r>
+              <a:t>Slide Purpose: Synthesize key insights and establish future principles for human-in-the-loop AI integration.</a:t>
+            </a:r>
+          </a:p>
+          <a:p/>
+          <a:p>
+            <a:r>
+              <a:t>Case Study / Real-World Application:</a:t>
+            </a:r>
+          </a:p>
+          <a:p>
+            <a:r>
+              <a:t>AMA position paper formalizing 'Augmented Intelligence' as the collaborative future standard for healthcare technology.</a:t>
             </a:r>
           </a:p>
           <a:p/>

</xml_diff>